<commit_message>
progress: correct v3 broad-mimic attribution + slide layout fixes in the deck
Fix the v3 contaminant slide: broad-mimic recovery 0.60->0.89 was the v3 head
re-ranker, not v3blend8 (0.790). Also fixes orphan bullets from spacer strings,
doubled list numbering, a subtitle placed over a figure, and two figures
overlapping adjacent text. Regenerate the .pptx.

Co-Authored-By: Claude Opus 4.8 (1M context) <noreply@anthropic.com>
</commit_message>
<xml_diff>
--- a/progress/2026-07-09/claudenet_v4_dr11_2026-07-09.pptx
+++ b/progress/2026-07-09/claudenet_v4_dr11_2026-07-09.pptx
@@ -6570,7 +6570,7 @@
         </p:nvSpPr>
         <p:spPr>
           <a:xfrm>
-            <a:off x="6080760" y="3429000"/>
+            <a:off x="6080760" y="3456432"/>
             <a:ext cx="5623560" cy="457200"/>
           </a:xfrm>
           <a:prstGeom prst="rect">
@@ -6590,7 +6590,7 @@
                   <a:srgbClr val="182C5B"/>
                 </a:solidFill>
               </a:rPr>
-              <a:t>Denominator discipline — three published readings, three different denominators:</a:t>
+              <a:t>Denominator discipline — three readings, three denominators:</a:t>
             </a:r>
           </a:p>
         </p:txBody>
@@ -6604,8 +6604,8 @@
           <p:nvPr/>
         </p:nvGraphicFramePr>
         <p:xfrm>
-          <a:off x="6080760" y="3822191"/>
-          <a:ext cx="5623560" cy="1920240"/>
+          <a:off x="6080760" y="3931920"/>
+          <a:ext cx="5623560" cy="1874519"/>
         </p:xfrm>
         <a:graphic>
           <a:graphicData uri="http://schemas.openxmlformats.org/drawingml/2006/table">
@@ -6618,7 +6618,7 @@
                 <a:gridCol w="1508760"/>
                 <a:gridCol w="1965960"/>
               </a:tblGrid>
-              <a:tr h="384048">
+              <a:tr h="374903">
                 <a:tc>
                   <a:txBody>
                     <a:bodyPr/>
@@ -6671,7 +6671,7 @@
                   <a:tcPr/>
                 </a:tc>
               </a:tr>
-              <a:tr h="384048">
+              <a:tr h="374903">
                 <a:tc>
                   <a:txBody>
                     <a:bodyPr/>
@@ -6724,7 +6724,7 @@
                   <a:tcPr/>
                 </a:tc>
               </a:tr>
-              <a:tr h="384048">
+              <a:tr h="374903">
                 <a:tc>
                   <a:txBody>
                     <a:bodyPr/>
@@ -6777,7 +6777,7 @@
                   <a:tcPr/>
                 </a:tc>
               </a:tr>
-              <a:tr h="384048">
+              <a:tr h="374903">
                 <a:tc>
                   <a:txBody>
                     <a:bodyPr/>
@@ -6830,7 +6830,7 @@
                   <a:tcPr/>
                 </a:tc>
               </a:tr>
-              <a:tr h="384048">
+              <a:tr h="374907">
                 <a:tc>
                   <a:txBody>
                     <a:bodyPr/>
@@ -7054,8 +7054,8 @@
         </p:blipFill>
         <p:spPr>
           <a:xfrm>
-            <a:off x="2553788" y="2606040"/>
-            <a:ext cx="7053943" cy="3291840"/>
+            <a:off x="2749731" y="2788920"/>
+            <a:ext cx="6662057" cy="3108960"/>
           </a:xfrm>
           <a:prstGeom prst="rect">
             <a:avLst/>
@@ -7747,7 +7747,7 @@
                   <a:srgbClr val="222222"/>
                 </a:solidFill>
               </a:rPr>
-              <a:t>• Still solid: broad-mimic recovery 0.598 → 0.885, and the LensJudge escalation flip (median p_lens 0.03 → 0.70 at 0.1″ on 134 real objects, ~90% agreement with Euclid experts on grade-A).</a:t>
+              <a:t>• Still solid: broad-mimic recovery 0.598 → 0.885 across the four generations (right panel), and the LensJudge escalation flip (median p_lens 0.03 → 0.70 at 0.1″ on 134 real objects, ~90% agreement with Euclid experts on grade-A).</a:t>
             </a:r>
           </a:p>
         </p:txBody>
@@ -11830,7 +11830,7 @@
                   <a:srgbClr val="222222"/>
                 </a:solidFill>
               </a:rPr>
-              <a:t>• Broad-mimic recovery across generations: 0.60 (original CNN) → 0.89 (v3).</a:t>
+              <a:t>• Broad-mimic recovery (DR10-eval): 0.598 original CNN → 0.790 v3blend8 → 0.885 with the v3 head re-ranker (deployed only as a φ=0.05 stage-2 re-rank).</a:t>
             </a:r>
           </a:p>
         </p:txBody>

</xml_diff>